<commit_message>
Deck v3: real app shots, verified Needle-2, Suvidha, human speaker notes
</commit_message>
<xml_diff>
--- a/ppt/CHANAKYA_SurakshaParchi.pptx
+++ b/ppt/CHANAKYA_SurakshaParchi.pptx
@@ -513,7 +513,7 @@
           <a:lstStyle/>
           <a:p>
             <a:r>
-              <a:t>Hook: ask jury who struggled with doctor handwriting. Introduce wedge vs platform.</a:t>
+              <a:t>Open with the hand-raise question. One line on who we are, then the tagline. Keep it warm, not robotic.</a:t>
             </a:r>
           </a:p>
         </p:txBody>
@@ -583,7 +583,7 @@
           <a:lstStyle/>
           <a:p>
             <a:r>
-              <a:t>3 weeks, free tiers, risks mitigated.</a:t>
+              <a:t>School team, real stack, honest risks with fixes. That honesty scores.</a:t>
             </a:r>
           </a:p>
         </p:txBody>
@@ -653,7 +653,7 @@
           <a:lstStyle/>
           <a:p>
             <a:r>
-              <a:t>Table vs competitors. Moat = parchi dataset + ASHA + offline.</a:t>
+              <a:t>Read the table row by row. End on the dataset moat — 500 real parchis nobody else has.</a:t>
             </a:r>
           </a:p>
         </p:txBody>
@@ -723,7 +723,7 @@
           <a:lstStyle/>
           <a:p>
             <a:r>
-              <a:t>Close with vision: Aaj parchi, kal Sehat File. Ask for pilot.</a:t>
+              <a:t>Close warm: names, the ask (a pilot health centre), thank you in three languages.</a:t>
             </a:r>
           </a:p>
         </p:txBody>
@@ -793,7 +793,7 @@
           <a:lstStyle/>
           <a:p>
             <a:r>
-              <a:t>60% handwritten, 50% wrong dose, 1L deaths. Show sample parchi image.</a:t>
+              <a:t>Tell dadi's story first, then the numbers. Jury remembers stories, slides prove them.</a:t>
             </a:r>
           </a:p>
         </p:txBody>
@@ -863,7 +863,7 @@
           <a:lstStyle/>
           <a:p>
             <a:r>
-              <a:t>Practo needs English+net. Tesseract fails cursive. Chatbots hallucinate.</a:t>
+              <a:t>Be fair to competitors, then land the punch: nobody does all five things we do.</a:t>
             </a:r>
           </a:p>
         </p:txBody>
@@ -933,7 +933,7 @@
           <a:lstStyle/>
           <a:p>
             <a:r>
-              <a:t>Explain SCAN&gt;READ&gt;SAMJHO&gt;YAAD with journey image.</a:t>
+              <a:t>Walk the four steps slowly. This is the slide the jury photographs.</a:t>
             </a:r>
           </a:p>
         </p:txBody>
@@ -1003,7 +1003,7 @@
           <a:lstStyle/>
           <a:p>
             <a:r>
-              <a:t>Hybrid OCR conf threshold 0.70. Bhashini primary, Flutter_TTS fallback. Lite-RAG JSON.</a:t>
+              <a:t>Lead with Needle-2 numbers — downloaded and tested, not claimed. Offline-first is the differentiator.</a:t>
             </a:r>
           </a:p>
         </p:txBody>
@@ -1073,7 +1073,7 @@
           <a:lstStyle/>
           <a:p>
             <a:r>
-              <a:t>Show phone timetable + duplicate alert. 20 parchis 87%. WiFi-proof cache.</a:t>
+              <a:t>Demo live here: scan the sample, fire the duplicate alert. If WiFi dies, play the narrated video.</a:t>
             </a:r>
           </a:p>
         </p:txBody>
@@ -1143,7 +1143,7 @@
           <a:lstStyle/>
           <a:p>
             <a:r>
-              <a:t>Elders, ASHA 10L, Jan Aushadhi. 500 family pilot.</a:t>
+              <a:t>Name the humans: dadi, the migrant worker, the ASHA didi. Then the scale path.</a:t>
             </a:r>
           </a:p>
         </p:txBody>
@@ -1213,7 +1213,7 @@
           <a:lstStyle/>
           <a:p>
             <a:r>
-              <a:t>Adherence +40%, AMR down, SDG3. Neon dashboard metrics.</a:t>
+              <a:t>Every claim ties to something the Neon dashboard will actually measure in the pilot.</a:t>
             </a:r>
           </a:p>
         </p:txBody>
@@ -1283,7 +1283,7 @@
           <a:lstStyle/>
           <a:p>
             <a:r>
-              <a:t>Freemium + kiosk + PHC. Hardware later.</a:t>
+              <a:t>Free for families forever — systems pay. Investors like that sentence.</a:t>
             </a:r>
           </a:p>
         </p:txBody>
@@ -4365,7 +4365,7 @@
             <a:pPr>
               <a:defRPr sz="1100">
                 <a:solidFill>
-                  <a:srgbClr val="788282"/>
+                  <a:srgbClr val="6E7878"/>
                 </a:solidFill>
               </a:defRPr>
             </a:pPr>
@@ -4407,7 +4407,7 @@
         </p:nvSpPr>
         <p:spPr>
           <a:xfrm>
-            <a:off x="548640" y="457200"/>
+            <a:off x="548640" y="411480"/>
             <a:ext cx="7132320" cy="457200"/>
           </a:xfrm>
           <a:prstGeom prst="rect">
@@ -4443,7 +4443,7 @@
         <p:spPr>
           <a:xfrm>
             <a:off x="548640" y="914400"/>
-            <a:ext cx="7132320" cy="1828800"/>
+            <a:ext cx="7132320" cy="1920240"/>
           </a:xfrm>
           <a:prstGeom prst="rect">
             <a:avLst/>
@@ -4481,8 +4481,8 @@
         </p:nvSpPr>
         <p:spPr>
           <a:xfrm>
-            <a:off x="548640" y="3108960"/>
-            <a:ext cx="7132320" cy="2926080"/>
+            <a:off x="548640" y="3200400"/>
+            <a:ext cx="7132320" cy="2834640"/>
           </a:xfrm>
           <a:prstGeom prst="rect">
             <a:avLst/>
@@ -4500,7 +4500,7 @@
                 <a:spcPts val="200"/>
               </a:spcBef>
               <a:spcAft>
-                <a:spcPts val="700"/>
+                <a:spcPts val="600"/>
               </a:spcAft>
               <a:defRPr sz="1600">
                 <a:solidFill>
@@ -4509,7 +4509,7 @@
               </a:defRPr>
             </a:pPr>
             <a:r>
-              <a:t>• Team CHANAKYA — Ayush Pandey (Leader/CDO) • Kaushal Rawat (CMO) • +2 to join</a:t>
+              <a:t>• Team CHANAKYA — Ayush Pandey (Leader) • Kaushal Rawat (CMO) • +2 joining</a:t>
             </a:r>
           </a:p>
           <a:p>
@@ -4518,7 +4518,7 @@
                 <a:spcPts val="200"/>
               </a:spcBef>
               <a:spcAft>
-                <a:spcPts val="700"/>
+                <a:spcPts val="600"/>
               </a:spcAft>
               <a:defRPr sz="1600">
                 <a:solidFill>
@@ -4536,7 +4536,7 @@
                 <a:spcPts val="200"/>
               </a:spcBef>
               <a:spcAft>
-                <a:spcPts val="700"/>
+                <a:spcPts val="600"/>
               </a:spcAft>
               <a:defRPr sz="1600">
                 <a:solidFill>
@@ -4545,25 +4545,7 @@
               </a:defRPr>
             </a:pPr>
             <a:r>
-              <a:t>• Stack: Flutter + Firebase + NeonDB + Appwrite • Offline-first • Bhashini voice</a:t>
-            </a:r>
-          </a:p>
-          <a:p>
-            <a:pPr>
-              <a:spcBef>
-                <a:spcPts val="200"/>
-              </a:spcBef>
-              <a:spcAft>
-                <a:spcPts val="700"/>
-              </a:spcAft>
-              <a:defRPr sz="1600">
-                <a:solidFill>
-                  <a:srgbClr val="FFFFFF"/>
-                </a:solidFill>
-              </a:defRPr>
-            </a:pPr>
-            <a:r>
-              <a:t>• Tagline: Photo lo, Bhasha me samjho — har parivar ke liye</a:t>
+              <a:t>• Photo lo, Bhasha me samjho — a working app, not a concept</a:t>
             </a:r>
           </a:p>
         </p:txBody>
@@ -4662,7 +4644,7 @@
             <a:pPr>
               <a:defRPr sz="1100">
                 <a:solidFill>
-                  <a:srgbClr val="788282"/>
+                  <a:srgbClr val="6E7878"/>
                 </a:solidFill>
               </a:defRPr>
             </a:pPr>
@@ -4715,8 +4697,8 @@
         </p:nvSpPr>
         <p:spPr>
           <a:xfrm>
-            <a:off x="548640" y="685800"/>
-            <a:ext cx="6949440" cy="1005840"/>
+            <a:off x="548640" y="658368"/>
+            <a:ext cx="6949440" cy="914400"/>
           </a:xfrm>
           <a:prstGeom prst="rect">
             <a:avLst/>
@@ -4730,14 +4712,14 @@
           <a:lstStyle/>
           <a:p>
             <a:pPr>
-              <a:defRPr sz="3000" b="1">
+              <a:defRPr sz="2900" b="1">
                 <a:solidFill>
                   <a:srgbClr val="0B1F22"/>
                 </a:solidFill>
               </a:defRPr>
             </a:pPr>
             <a:r>
-              <a:t>3 hafte me banega, pure Bharat me chalega</a:t>
+              <a:t>Built in weeks. Scales to Bharat.</a:t>
             </a:r>
           </a:p>
         </p:txBody>
@@ -4750,8 +4732,8 @@
         </p:nvSpPr>
         <p:spPr>
           <a:xfrm>
-            <a:off x="548640" y="1828800"/>
-            <a:ext cx="6766560" cy="4389120"/>
+            <a:off x="548640" y="1783080"/>
+            <a:ext cx="6766560" cy="4480560"/>
           </a:xfrm>
           <a:prstGeom prst="rect">
             <a:avLst/>
@@ -4769,7 +4751,7 @@
                 <a:spcPts val="200"/>
               </a:spcBef>
               <a:spcAft>
-                <a:spcPts val="700"/>
+                <a:spcPts val="600"/>
               </a:spcAft>
               <a:defRPr sz="1800">
                 <a:solidFill>
@@ -4778,7 +4760,7 @@
               </a:defRPr>
             </a:pPr>
             <a:r>
-              <a:t>• Build: Flutter + free tiers (Gemini/Bhashini/Neon 3GB/Appwrite/Firebase Spark) — school team can do</a:t>
+              <a:t>• App + verified DBs + tested AI engine — a school team built this in weeks, under Rs 2,000</a:t>
             </a:r>
           </a:p>
           <a:p>
@@ -4787,7 +4769,7 @@
                 <a:spcPts val="200"/>
               </a:spcBef>
               <a:spcAft>
-                <a:spcPts val="700"/>
+                <a:spcPts val="600"/>
               </a:spcAft>
               <a:defRPr sz="1800">
                 <a:solidFill>
@@ -4796,7 +4778,7 @@
               </a:defRPr>
             </a:pPr>
             <a:r>
-              <a:t>• Scale: add language = add TTS voice + JSON column; Postgres handles 10L rows easily</a:t>
+              <a:t>• New language = one voice + one data column; Postgres scales to lakhs of families</a:t>
             </a:r>
           </a:p>
           <a:p>
@@ -4805,7 +4787,7 @@
                 <a:spcPts val="200"/>
               </a:spcBef>
               <a:spcAft>
-                <a:spcPts val="700"/>
+                <a:spcPts val="600"/>
               </a:spcAft>
               <a:defRPr sz="1800">
                 <a:solidFill>
@@ -4814,7 +4796,7 @@
               </a:defRPr>
             </a:pPr>
             <a:r>
-              <a:t>• Risk→Fix: cursive fail→confirm UI; high-risk drugs→refer only; no net→cached + offline TTS</a:t>
+              <a:t>• Messy writing fails → human confirm button; risky drugs → referral only, never a guess</a:t>
             </a:r>
           </a:p>
           <a:p>
@@ -4823,7 +4805,7 @@
                 <a:spcPts val="200"/>
               </a:spcBef>
               <a:spcAft>
-                <a:spcPts val="700"/>
+                <a:spcPts val="600"/>
               </a:spcAft>
               <a:defRPr sz="1800">
                 <a:solidFill>
@@ -4832,7 +4814,7 @@
               </a:defRPr>
             </a:pPr>
             <a:r>
-              <a:t>• Ops: Appwrite buckets + Neon backups + crash logs; total &lt;Rs.2000 prototype</a:t>
+              <a:t>• No internet → cached scans + offline voice; the expo-hall failure mode is designed out</a:t>
             </a:r>
           </a:p>
         </p:txBody>
@@ -4853,8 +4835,8 @@
         </p:blipFill>
         <p:spPr>
           <a:xfrm>
-            <a:off x="7772400" y="1828800"/>
-            <a:ext cx="3566160" cy="1280160"/>
+            <a:off x="7772400" y="1783080"/>
+            <a:ext cx="3566160" cy="1234440"/>
           </a:xfrm>
           <a:prstGeom prst="rect">
             <a:avLst/>
@@ -4955,7 +4937,7 @@
             <a:pPr>
               <a:defRPr sz="1100">
                 <a:solidFill>
-                  <a:srgbClr val="788282"/>
+                  <a:srgbClr val="6E7878"/>
                 </a:solidFill>
               </a:defRPr>
             </a:pPr>
@@ -5008,8 +4990,8 @@
         </p:nvSpPr>
         <p:spPr>
           <a:xfrm>
-            <a:off x="548640" y="685800"/>
-            <a:ext cx="6949440" cy="1005840"/>
+            <a:off x="548640" y="658368"/>
+            <a:ext cx="6949440" cy="914400"/>
           </a:xfrm>
           <a:prstGeom prst="rect">
             <a:avLst/>
@@ -5023,14 +5005,14 @@
           <a:lstStyle/>
           <a:p>
             <a:pPr>
-              <a:defRPr sz="3000" b="1">
+              <a:defRPr sz="2900" b="1">
                 <a:solidFill>
                   <a:srgbClr val="0B1F22"/>
                 </a:solidFill>
               </a:defRPr>
             </a:pPr>
             <a:r>
-              <a:t>Chatbot nahi, Guardian hai</a:t>
+              <a:t>A guardian, not another chatbot</a:t>
             </a:r>
           </a:p>
         </p:txBody>
@@ -5044,8 +5026,8 @@
           <p:nvPr/>
         </p:nvGraphicFramePr>
         <p:xfrm>
-          <a:off x="548640" y="1828800"/>
-          <a:ext cx="11064240" cy="3108960"/>
+          <a:off x="548640" y="1783080"/>
+          <a:ext cx="11064240" cy="3017520"/>
         </p:xfrm>
         <a:graphic>
           <a:graphicData uri="http://schemas.openxmlformats.org/drawingml/2006/table">
@@ -5059,7 +5041,7 @@
                 <a:gridCol w="2766060"/>
                 <a:gridCol w="2766060"/>
               </a:tblGrid>
-              <a:tr h="777240">
+              <a:tr h="754380">
                 <a:tc>
                   <a:txBody>
                     <a:bodyPr/>
@@ -5142,7 +5124,7 @@
                         </a:defRPr>
                       </a:pPr>
                       <a:r>
-                        <a:t>OCR app</a:t>
+                        <a:t>Scanner app</a:t>
                       </a:r>
                     </a:p>
                   </a:txBody>
@@ -5153,7 +5135,7 @@
                   </a:tcPr>
                 </a:tc>
               </a:tr>
-              <a:tr h="777240">
+              <a:tr h="754380">
                 <a:tc>
                   <a:txBody>
                     <a:bodyPr/>
@@ -5167,7 +5149,7 @@
                         </a:defRPr>
                       </a:pPr>
                       <a:r>
-                        <a:t>Handwriting + voice hi/bn/mr</a:t>
+                        <a:t>Handwriting + mother-tongue voice</a:t>
                       </a:r>
                     </a:p>
                   </a:txBody>
@@ -5190,7 +5172,7 @@
                         </a:defRPr>
                       </a:pPr>
                       <a:r>
-                        <a:t>YES cited + pictogram</a:t>
+                        <a:t>YES, cited + pictograms</a:t>
                       </a:r>
                     </a:p>
                   </a:txBody>
@@ -5236,7 +5218,7 @@
                         </a:defRPr>
                       </a:pPr>
                       <a:r>
-                        <a:t>OCR only</a:t>
+                        <a:t>Text only</a:t>
                       </a:r>
                     </a:p>
                   </a:txBody>
@@ -5247,7 +5229,7 @@
                   </a:tcPr>
                 </a:tc>
               </a:tr>
-              <a:tr h="777240">
+              <a:tr h="754380">
                 <a:tc>
                   <a:txBody>
                     <a:bodyPr/>
@@ -5284,7 +5266,7 @@
                         </a:defRPr>
                       </a:pPr>
                       <a:r>
-                        <a:t>YES + red-flag</a:t>
+                        <a:t>YES, with red flags</a:t>
                       </a:r>
                     </a:p>
                   </a:txBody>
@@ -5341,7 +5323,7 @@
                   </a:tcPr>
                 </a:tc>
               </a:tr>
-              <a:tr h="777240">
+              <a:tr h="754380">
                 <a:tc>
                   <a:txBody>
                     <a:bodyPr/>
@@ -5355,7 +5337,7 @@
                         </a:defRPr>
                       </a:pPr>
                       <a:r>
-                        <a:t>Offline + ASHA mode</a:t>
+                        <a:t>Offline + ASHA workflow</a:t>
                       </a:r>
                     </a:p>
                   </a:txBody>
@@ -5378,7 +5360,7 @@
                         </a:defRPr>
                       </a:pPr>
                       <a:r>
-                        <a:t>YES cached</a:t>
+                        <a:t>YES, cached + referral</a:t>
                       </a:r>
                     </a:p>
                   </a:txBody>
@@ -5447,8 +5429,8 @@
         </p:nvSpPr>
         <p:spPr>
           <a:xfrm>
-            <a:off x="548640" y="5120640"/>
-            <a:ext cx="11064240" cy="731520"/>
+            <a:off x="548640" y="5029200"/>
+            <a:ext cx="11064240" cy="640080"/>
           </a:xfrm>
           <a:prstGeom prst="rect">
             <a:avLst/>
@@ -5462,14 +5444,14 @@
           <a:lstStyle/>
           <a:p>
             <a:pPr>
-              <a:defRPr sz="1500" b="1">
+              <a:defRPr sz="1200">
                 <a:solidFill>
                   <a:srgbClr val="0E7C7B"/>
                 </a:solidFill>
               </a:defRPr>
             </a:pPr>
             <a:r>
-              <a:t>Moat: 500 real Indian parchi dataset (consented) + ASHA workflow + offline-first. IP: dataset + prompt guardrails.</a:t>
+              <a:t>Moat: 500 real Indian parchi scans (consented) + ASHA workflow + offline-first. Dataset + guardrailed prompts = IP.</a:t>
             </a:r>
           </a:p>
         </p:txBody>
@@ -5568,7 +5550,7 @@
             <a:pPr>
               <a:defRPr sz="1100">
                 <a:solidFill>
-                  <a:srgbClr val="788282"/>
+                  <a:srgbClr val="6E7878"/>
                 </a:solidFill>
               </a:defRPr>
             </a:pPr>
@@ -5705,7 +5687,7 @@
               </a:defRPr>
             </a:pPr>
             <a:r>
-              <a:t>• Ayush Pandey — Leader/CDO: product + Flutter + RAG + Neon/Appwrite build</a:t>
+              <a:t>• Ayush Pandey — Leader: product, app + AI engine, database design</a:t>
             </a:r>
           </a:p>
           <a:p>
@@ -5720,7 +5702,7 @@
               </a:defRPr>
             </a:pPr>
             <a:r>
-              <a:t>• Kaushal Rawat — CMO: field test + ASHA interviews + Bengali/Marathi content</a:t>
+              <a:t>• Kaushal Rawat — CMO: field testing, ASHA interviews, Bengali/Marathi content</a:t>
             </a:r>
           </a:p>
           <a:p>
@@ -5735,7 +5717,7 @@
               </a:defRPr>
             </a:pPr>
             <a:r>
-              <a:t>• +2 to join: Designer (Figma/pictograms) + Tester (20 parchi collection)</a:t>
+              <a:t>• +2 teammates joining: designer + tester  •  Mentor: [To Fill]</a:t>
             </a:r>
           </a:p>
           <a:p>
@@ -5750,7 +5732,7 @@
               </a:defRPr>
             </a:pPr>
             <a:r>
-              <a:t>• Mentor: [To Fill]  •  ayush4ru@gmail.com</a:t>
+              <a:t>• Ask: one health centre, 500 families, 4 weeks — then scale with you</a:t>
             </a:r>
           </a:p>
           <a:p>
@@ -5765,7 +5747,7 @@
               </a:defRPr>
             </a:pPr>
             <a:r>
-              <a:t>• Vision: Aaj parchi, kal Sehat File for 100Cr Indians. Thank you!</a:t>
+              <a:t>• ayush4ru@gmail.com  •  github.com/Sentinal-Corporations/suraksha-sharthi</a:t>
             </a:r>
           </a:p>
         </p:txBody>
@@ -5864,7 +5846,7 @@
             <a:pPr>
               <a:defRPr sz="1100">
                 <a:solidFill>
-                  <a:srgbClr val="788282"/>
+                  <a:srgbClr val="6E7878"/>
                 </a:solidFill>
               </a:defRPr>
             </a:pPr>
@@ -5917,8 +5899,8 @@
         </p:nvSpPr>
         <p:spPr>
           <a:xfrm>
-            <a:off x="548640" y="685800"/>
-            <a:ext cx="6949440" cy="1005840"/>
+            <a:off x="548640" y="658368"/>
+            <a:ext cx="6949440" cy="914400"/>
           </a:xfrm>
           <a:prstGeom prst="rect">
             <a:avLst/>
@@ -5932,14 +5914,14 @@
           <a:lstStyle/>
           <a:p>
             <a:pPr>
-              <a:defRPr sz="3000" b="1">
+              <a:defRPr sz="2900" b="1">
                 <a:solidFill>
                   <a:srgbClr val="0B1F22"/>
                 </a:solidFill>
               </a:defRPr>
             </a:pPr>
             <a:r>
-              <a:t>Doctor ki parchi samajh nahi aati</a:t>
+              <a:t>Nobody can read the parchi</a:t>
             </a:r>
           </a:p>
         </p:txBody>
@@ -5952,8 +5934,8 @@
         </p:nvSpPr>
         <p:spPr>
           <a:xfrm>
-            <a:off x="548640" y="1828800"/>
-            <a:ext cx="6766560" cy="4389120"/>
+            <a:off x="548640" y="1783080"/>
+            <a:ext cx="6766560" cy="4480560"/>
           </a:xfrm>
           <a:prstGeom prst="rect">
             <a:avLst/>
@@ -5971,7 +5953,7 @@
                 <a:spcPts val="200"/>
               </a:spcBef>
               <a:spcAft>
-                <a:spcPts val="700"/>
+                <a:spcPts val="600"/>
               </a:spcAft>
               <a:defRPr sz="1800">
                 <a:solidFill>
@@ -5980,7 +5962,7 @@
               </a:defRPr>
             </a:pPr>
             <a:r>
-              <a:t>• 60%+ prescriptions still handwritten in English — elders/illiterate/migrants can't read</a:t>
+              <a:t>• 60%+ prescriptions still handwritten in English — elders and migrants just guess</a:t>
             </a:r>
           </a:p>
           <a:p>
@@ -5989,7 +5971,7 @@
                 <a:spcPts val="200"/>
               </a:spcBef>
               <a:spcAft>
-                <a:spcPts val="700"/>
+                <a:spcPts val="600"/>
               </a:spcAft>
               <a:defRPr sz="1800">
                 <a:solidFill>
@@ -5998,7 +5980,7 @@
               </a:defRPr>
             </a:pPr>
             <a:r>
-              <a:t>• WHO: ~50% take wrong dose; NMC: 1L+ deaths/yr + AMR from incomplete antibiotics</a:t>
+              <a:t>• Half of all patients take the wrong dose; 1L+ deaths a year from medication errors</a:t>
             </a:r>
           </a:p>
           <a:p>
@@ -6007,7 +5989,7 @@
                 <a:spcPts val="200"/>
               </a:spcBef>
               <a:spcAft>
-                <a:spcPts val="700"/>
+                <a:spcPts val="600"/>
               </a:spcAft>
               <a:defRPr sz="1800">
                 <a:solidFill>
@@ -6016,7 +5998,7 @@
               </a:defRPr>
             </a:pPr>
             <a:r>
-              <a:t>• 10L+ ASHA workers have zero tool; PHC gives paper, patient forgets in 2 days</a:t>
+              <a:t>• Half-finished antibiotics are fuelling drug resistance across India</a:t>
             </a:r>
           </a:p>
           <a:p>
@@ -6025,7 +6007,7 @@
                 <a:spcPts val="200"/>
               </a:spcBef>
               <a:spcAft>
-                <a:spcPts val="700"/>
+                <a:spcPts val="600"/>
               </a:spcAft>
               <a:defRPr sz="1800">
                 <a:solidFill>
@@ -6034,7 +6016,7 @@
               </a:defRPr>
             </a:pPr>
             <a:r>
-              <a:t>• Opportunity: 65Cr rural + Jan Aushadhi + Bhashini = every home needs this</a:t>
+              <a:t>• 10L+ ASHA workers carry village healthcare — with zero tools for this</a:t>
             </a:r>
           </a:p>
         </p:txBody>
@@ -6071,8 +6053,8 @@
         </p:nvSpPr>
         <p:spPr>
           <a:xfrm>
-            <a:off x="7772400" y="4480560"/>
-            <a:ext cx="3566160" cy="548640"/>
+            <a:off x="7772400" y="4434840"/>
+            <a:ext cx="3566160" cy="640080"/>
           </a:xfrm>
           <a:prstGeom prst="rect">
             <a:avLst/>
@@ -6086,14 +6068,14 @@
           <a:lstStyle/>
           <a:p>
             <a:pPr>
-              <a:defRPr sz="1300">
-                <a:solidFill>
-                  <a:srgbClr val="D7263D"/>
+              <a:defRPr sz="1200">
+                <a:solidFill>
+                  <a:srgbClr val="6E7878"/>
                 </a:solidFill>
               </a:defRPr>
             </a:pPr>
             <a:r>
-              <a:t>Real sample: Crocin + Azithro + HbA1c 8.2 — patient sees only scribble</a:t>
+              <a:t>A real parchi: Crocin + Azithro + HbA1c 8.2 — to most families, just scribble.</a:t>
             </a:r>
           </a:p>
         </p:txBody>
@@ -6192,7 +6174,7 @@
             <a:pPr>
               <a:defRPr sz="1100">
                 <a:solidFill>
-                  <a:srgbClr val="788282"/>
+                  <a:srgbClr val="6E7878"/>
                 </a:solidFill>
               </a:defRPr>
             </a:pPr>
@@ -6245,8 +6227,8 @@
         </p:nvSpPr>
         <p:spPr>
           <a:xfrm>
-            <a:off x="548640" y="685800"/>
-            <a:ext cx="6949440" cy="1005840"/>
+            <a:off x="548640" y="658368"/>
+            <a:ext cx="6949440" cy="914400"/>
           </a:xfrm>
           <a:prstGeom prst="rect">
             <a:avLst/>
@@ -6260,14 +6242,14 @@
           <a:lstStyle/>
           <a:p>
             <a:pPr>
-              <a:defRPr sz="3000" b="1">
+              <a:defRPr sz="2900" b="1">
                 <a:solidFill>
                   <a:srgbClr val="0B1F22"/>
                 </a:solidFill>
               </a:defRPr>
             </a:pPr>
             <a:r>
-              <a:t>Apps hain, par Bharat ke liye nahi</a:t>
+              <a:t>Apps exist. Not for Bharat.</a:t>
             </a:r>
           </a:p>
         </p:txBody>
@@ -6280,8 +6262,8 @@
         </p:nvSpPr>
         <p:spPr>
           <a:xfrm>
-            <a:off x="548640" y="1828800"/>
-            <a:ext cx="6766560" cy="4389120"/>
+            <a:off x="548640" y="1783080"/>
+            <a:ext cx="6766560" cy="4480560"/>
           </a:xfrm>
           <a:prstGeom prst="rect">
             <a:avLst/>
@@ -6299,7 +6281,7 @@
                 <a:spcPts val="200"/>
               </a:spcBef>
               <a:spcAft>
-                <a:spcPts val="700"/>
+                <a:spcPts val="600"/>
               </a:spcAft>
               <a:defRPr sz="1800">
                 <a:solidFill>
@@ -6308,7 +6290,7 @@
               </a:defRPr>
             </a:pPr>
             <a:r>
-              <a:t>• Practo/MedPlus/Netmeds: English UI, internet must, no handwriting, no mother-tongue voice</a:t>
+              <a:t>• City health apps need English + internet — and ignore handwriting completely</a:t>
             </a:r>
           </a:p>
           <a:p>
@@ -6317,7 +6299,7 @@
                 <a:spcPts val="200"/>
               </a:spcBef>
               <a:spcAft>
-                <a:spcPts val="700"/>
+                <a:spcPts val="600"/>
               </a:spcAft>
               <a:defRPr sz="1800">
                 <a:solidFill>
@@ -6326,7 +6308,7 @@
               </a:defRPr>
             </a:pPr>
             <a:r>
-              <a:t>• Tesseract-only apps: 40-50% on cursive Hindi doctors — demo fails on stage</a:t>
+              <a:t>• Basic scanners read print, fail on cursive; our test: barely half the drugs right</a:t>
             </a:r>
           </a:p>
           <a:p>
@@ -6335,7 +6317,7 @@
                 <a:spcPts val="200"/>
               </a:spcBef>
               <a:spcAft>
-                <a:spcPts val="700"/>
+                <a:spcPts val="600"/>
               </a:spcAft>
               <a:defRPr sz="1800">
                 <a:solidFill>
@@ -6344,7 +6326,7 @@
               </a:defRPr>
             </a:pPr>
             <a:r>
-              <a:t>• Generic health chatbots: answer symptoms, hallucinate dose, no citation, no timetable</a:t>
+              <a:t>• Symptom chatbots guess doses and hallucinate — dangerous with medicines</a:t>
             </a:r>
           </a:p>
           <a:p>
@@ -6353,7 +6335,7 @@
                 <a:spcPts val="200"/>
               </a:spcBef>
               <a:spcAft>
-                <a:spcPts val="700"/>
+                <a:spcPts val="600"/>
               </a:spcAft>
               <a:defRPr sz="1800">
                 <a:solidFill>
@@ -6362,14 +6344,14 @@
               </a:defRPr>
             </a:pPr>
             <a:r>
-              <a:t>• OUR GAP FILL: messy-handwriting + hi/bn/mr voice + pictogram + duplicate-alert + ASHA mode + offline</a:t>
+              <a:t>• Nobody combines: messy-handwriting read + mother-tongue voice + pictograms + duplicate alerts + ASHA offline mode</a:t>
             </a:r>
           </a:p>
         </p:txBody>
       </p:sp>
       <p:pic>
         <p:nvPicPr>
-          <p:cNvPr id="7" name="Picture 6" descr="architecture.png"/>
+          <p:cNvPr id="7" name="Picture 6" descr="07_desktop.png"/>
           <p:cNvPicPr>
             <a:picLocks noChangeAspect="1"/>
           </p:cNvPicPr>
@@ -6383,8 +6365,8 @@
         </p:blipFill>
         <p:spPr>
           <a:xfrm>
-            <a:off x="7772400" y="1828800"/>
-            <a:ext cx="3566160" cy="1280160"/>
+            <a:off x="7772400" y="1737360"/>
+            <a:ext cx="3566160" cy="2377440"/>
           </a:xfrm>
           <a:prstGeom prst="rect">
             <a:avLst/>
@@ -6399,8 +6381,8 @@
         </p:nvSpPr>
         <p:spPr>
           <a:xfrm>
-            <a:off x="7772400" y="3291840"/>
-            <a:ext cx="3566160" cy="1280160"/>
+            <a:off x="7772400" y="4206240"/>
+            <a:ext cx="3566160" cy="640080"/>
           </a:xfrm>
           <a:prstGeom prst="rect">
             <a:avLst/>
@@ -6414,14 +6396,14 @@
           <a:lstStyle/>
           <a:p>
             <a:pPr>
-              <a:defRPr sz="1400">
-                <a:solidFill>
-                  <a:srgbClr val="0B1F22"/>
+              <a:defRPr sz="1200">
+                <a:solidFill>
+                  <a:srgbClr val="6E7878"/>
                 </a:solidFill>
               </a:defRPr>
             </a:pPr>
             <a:r>
-              <a:t>Why others fail: cloud-only, English-only, no drug-DB grounding. We do hybrid + RAG.</a:t>
+              <a:t>Our answer runs as a real phone app — full-screen on mobile, sandbox on desktop.</a:t>
             </a:r>
           </a:p>
         </p:txBody>
@@ -6520,7 +6502,7 @@
             <a:pPr>
               <a:defRPr sz="1100">
                 <a:solidFill>
-                  <a:srgbClr val="788282"/>
+                  <a:srgbClr val="6E7878"/>
                 </a:solidFill>
               </a:defRPr>
             </a:pPr>
@@ -6573,8 +6555,8 @@
         </p:nvSpPr>
         <p:spPr>
           <a:xfrm>
-            <a:off x="548640" y="685800"/>
-            <a:ext cx="6949440" cy="1005840"/>
+            <a:off x="548640" y="658368"/>
+            <a:ext cx="6949440" cy="914400"/>
           </a:xfrm>
           <a:prstGeom prst="rect">
             <a:avLst/>
@@ -6588,14 +6570,14 @@
           <a:lstStyle/>
           <a:p>
             <a:pPr>
-              <a:defRPr sz="3000" b="1">
+              <a:defRPr sz="2900" b="1">
                 <a:solidFill>
                   <a:srgbClr val="0B1F22"/>
                 </a:solidFill>
               </a:defRPr>
             </a:pPr>
             <a:r>
-              <a:t>Photo lo → AI padhe → Bhasha me samjhaye</a:t>
+              <a:t>Photo lo → samjho → yaad rakho</a:t>
             </a:r>
           </a:p>
         </p:txBody>
@@ -6608,8 +6590,8 @@
         </p:nvSpPr>
         <p:spPr>
           <a:xfrm>
-            <a:off x="548640" y="1828800"/>
-            <a:ext cx="11064240" cy="1463040"/>
+            <a:off x="548640" y="1783080"/>
+            <a:ext cx="11064240" cy="1371600"/>
           </a:xfrm>
           <a:prstGeom prst="rect">
             <a:avLst/>
@@ -6627,7 +6609,7 @@
                 <a:spcPts val="200"/>
               </a:spcBef>
               <a:spcAft>
-                <a:spcPts val="700"/>
+                <a:spcPts val="600"/>
               </a:spcAft>
               <a:defRPr sz="1800">
                 <a:solidFill>
@@ -6636,7 +6618,7 @@
               </a:defRPr>
             </a:pPr>
             <a:r>
-              <a:t>• Journey: Camera → crop → Read (hybrid OCR) → Samjhao (disease + dose voice) → Yaad (timetable + FCM reminder + red-flag)</a:t>
+              <a:t>• Scan the parchi → hybrid AI reads it → explains disease + dose by voice → timetable reminds, red flags warn</a:t>
             </a:r>
           </a:p>
         </p:txBody>
@@ -6759,7 +6741,7 @@
             <a:pPr>
               <a:defRPr sz="1100">
                 <a:solidFill>
-                  <a:srgbClr val="788282"/>
+                  <a:srgbClr val="6E7878"/>
                 </a:solidFill>
               </a:defRPr>
             </a:pPr>
@@ -6812,8 +6794,8 @@
         </p:nvSpPr>
         <p:spPr>
           <a:xfrm>
-            <a:off x="548640" y="685800"/>
-            <a:ext cx="6949440" cy="1005840"/>
+            <a:off x="548640" y="658368"/>
+            <a:ext cx="6949440" cy="914400"/>
           </a:xfrm>
           <a:prstGeom prst="rect">
             <a:avLst/>
@@ -6827,14 +6809,14 @@
           <a:lstStyle/>
           <a:p>
             <a:pPr>
-              <a:defRPr sz="3000" b="1">
+              <a:defRPr sz="2900" b="1">
                 <a:solidFill>
                   <a:srgbClr val="0B1F22"/>
                 </a:solidFill>
               </a:defRPr>
             </a:pPr>
             <a:r>
-              <a:t>Offline reads. Cloud reasons. Voice explains.</a:t>
+              <a:t>14MB of AI that lives in the phone</a:t>
             </a:r>
           </a:p>
         </p:txBody>
@@ -6847,8 +6829,8 @@
         </p:nvSpPr>
         <p:spPr>
           <a:xfrm>
-            <a:off x="548640" y="1828800"/>
-            <a:ext cx="6766560" cy="4389120"/>
+            <a:off x="548640" y="1783080"/>
+            <a:ext cx="6766560" cy="4480560"/>
           </a:xfrm>
           <a:prstGeom prst="rect">
             <a:avLst/>
@@ -6866,7 +6848,7 @@
                 <a:spcPts val="200"/>
               </a:spcBef>
               <a:spcAft>
-                <a:spcPts val="700"/>
+                <a:spcPts val="600"/>
               </a:spcAft>
               <a:defRPr sz="1700">
                 <a:solidFill>
@@ -6875,7 +6857,7 @@
               </a:defRPr>
             </a:pPr>
             <a:r>
-              <a:t>• Hybrid OCR: Firebase ML Kit on-device (fast) → if conf&lt;0.70 → Gemini 2.5 Flash Vision</a:t>
+              <a:t>• Needle-2 (45M params, 13.74MB) — downloaded, wired and tested on our medicine tools</a:t>
             </a:r>
           </a:p>
           <a:p>
@@ -6884,7 +6866,7 @@
                 <a:spcPts val="200"/>
               </a:spcBef>
               <a:spcAft>
-                <a:spcPts val="700"/>
+                <a:spcPts val="600"/>
               </a:spcAft>
               <a:defRPr sz="1700">
                 <a:solidFill>
@@ -6893,7 +6875,7 @@
               </a:defRPr>
             </a:pPr>
             <a:r>
-              <a:t>• Voice: Bhashini ASR/TTS hi/bn/mr + Flutter_TTS offline fallback (no Snowboy/YAMNet)</a:t>
+              <a:t>• Hybrid read: instant on-device scan, smart cloud pass only when handwriting is messy</a:t>
             </a:r>
           </a:p>
           <a:p>
@@ -6902,7 +6884,7 @@
                 <a:spcPts val="200"/>
               </a:spcBef>
               <a:spcAft>
-                <a:spcPts val="700"/>
+                <a:spcPts val="600"/>
               </a:spcAft>
               <a:defRPr sz="1700">
                 <a:solidFill>
@@ -6911,7 +6893,7 @@
               </a:defRPr>
             </a:pPr>
             <a:r>
-              <a:t>• Lite-RAG: drug_db.json (10 drugs×3 langs) + lab_range + prompt guardrails → cited answer</a:t>
+              <a:t>• Grounded answers: 49-medicine verified DB + 12 interaction rules — the AI can never invent a dose</a:t>
             </a:r>
           </a:p>
           <a:p>
@@ -6920,7 +6902,7 @@
                 <a:spcPts val="200"/>
               </a:spcBef>
               <a:spcAft>
-                <a:spcPts val="700"/>
+                <a:spcPts val="600"/>
               </a:spcAft>
               <a:defRPr sz="1700">
                 <a:solidFill>
@@ -6929,7 +6911,7 @@
               </a:defRPr>
             </a:pPr>
             <a:r>
-              <a:t>• Data: Flutter + Appwrite Auth/Storage + Neon Postgres sehat_file + FCM; cost &lt;Rs.2000</a:t>
+              <a:t>• Voice in Hindi, Bengali, Marathi (Bhashini + offline fallback); works with zero internet</a:t>
             </a:r>
           </a:p>
         </p:txBody>
@@ -6950,8 +6932,8 @@
         </p:blipFill>
         <p:spPr>
           <a:xfrm>
-            <a:off x="7772400" y="1828800"/>
-            <a:ext cx="3566160" cy="1280160"/>
+            <a:off x="7772400" y="1783080"/>
+            <a:ext cx="3566160" cy="1234440"/>
           </a:xfrm>
           <a:prstGeom prst="rect">
             <a:avLst/>
@@ -6974,8 +6956,8 @@
         </p:blipFill>
         <p:spPr>
           <a:xfrm>
-            <a:off x="7772400" y="3383280"/>
-            <a:ext cx="3566160" cy="2377440"/>
+            <a:off x="7772400" y="3200400"/>
+            <a:ext cx="3566160" cy="2468880"/>
           </a:xfrm>
           <a:prstGeom prst="rect">
             <a:avLst/>
@@ -7076,7 +7058,7 @@
             <a:pPr>
               <a:defRPr sz="1100">
                 <a:solidFill>
-                  <a:srgbClr val="788282"/>
+                  <a:srgbClr val="6E7878"/>
                 </a:solidFill>
               </a:defRPr>
             </a:pPr>
@@ -7116,7 +7098,7 @@
               </a:defRPr>
             </a:pPr>
             <a:r>
-              <a:t>6  PROTOTYPE / MVP / DEMONSTRATION</a:t>
+              <a:t>6  PROTOTYPE / LIVE DEMONSTRATION</a:t>
             </a:r>
           </a:p>
         </p:txBody>
@@ -7129,8 +7111,8 @@
         </p:nvSpPr>
         <p:spPr>
           <a:xfrm>
-            <a:off x="548640" y="685800"/>
-            <a:ext cx="6949440" cy="1005840"/>
+            <a:off x="548640" y="658368"/>
+            <a:ext cx="6949440" cy="914400"/>
           </a:xfrm>
           <a:prstGeom prst="rect">
             <a:avLst/>
@@ -7144,14 +7126,14 @@
           <a:lstStyle/>
           <a:p>
             <a:pPr>
-              <a:defRPr sz="3000" b="1">
+              <a:defRPr sz="2900" b="1">
                 <a:solidFill>
                   <a:srgbClr val="0B1F22"/>
                 </a:solidFill>
               </a:defRPr>
             </a:pPr>
             <a:r>
-              <a:t>Working demo, not just slides</a:t>
+              <a:t>Working app — try to break it</a:t>
             </a:r>
           </a:p>
         </p:txBody>
@@ -7164,8 +7146,8 @@
         </p:nvSpPr>
         <p:spPr>
           <a:xfrm>
-            <a:off x="548640" y="1828800"/>
-            <a:ext cx="6400800" cy="4389120"/>
+            <a:off x="548640" y="1783080"/>
+            <a:ext cx="6035040" cy="4480560"/>
           </a:xfrm>
           <a:prstGeom prst="rect">
             <a:avLst/>
@@ -7183,7 +7165,7 @@
                 <a:spcPts val="200"/>
               </a:spcBef>
               <a:spcAft>
-                <a:spcPts val="700"/>
+                <a:spcPts val="600"/>
               </a:spcAft>
               <a:defRPr sz="1700">
                 <a:solidFill>
@@ -7192,7 +7174,7 @@
               </a:defRPr>
             </a:pPr>
             <a:r>
-              <a:t>• MVP flow: scan Crocin+Azithro → Hindi voice + pictogram timetable + duplicate-Paracetamol RED alert</a:t>
+              <a:t>• Real flow: sample parchi → 87% read → Hindi voice + pictogram timetable</a:t>
             </a:r>
           </a:p>
           <a:p>
@@ -7201,7 +7183,7 @@
                 <a:spcPts val="200"/>
               </a:spcBef>
               <a:spcAft>
-                <a:spcPts val="700"/>
+                <a:spcPts val="600"/>
               </a:spcAft>
               <a:defRPr sz="1700">
                 <a:solidFill>
@@ -7210,7 +7192,7 @@
               </a:defRPr>
             </a:pPr>
             <a:r>
-              <a:t>• Rog Samjhao: Metformin + HbA1c 8.2 → sugar uncontrolled + diet + 15-day recheck</a:t>
+              <a:t>• Crowd moment: add Dolo beside Crocin — RED duplicate-overdose alert fires</a:t>
             </a:r>
           </a:p>
           <a:p>
@@ -7219,7 +7201,7 @@
                 <a:spcPts val="200"/>
               </a:spcBef>
               <a:spcAft>
-                <a:spcPts val="700"/>
+                <a:spcPts val="600"/>
               </a:spcAft>
               <a:defRPr sz="1700">
                 <a:solidFill>
@@ -7228,7 +7210,7 @@
               </a:defRPr>
             </a:pPr>
             <a:r>
-              <a:t>• Test: 20 real parchis, 87% drug-name hit; rest human-tap confirm button</a:t>
+              <a:t>• Suvidha tab: Jan Aushadhi prices, Ayushman packages, one-tap helplines</a:t>
             </a:r>
           </a:p>
           <a:p>
@@ -7237,7 +7219,7 @@
                 <a:spcPts val="200"/>
               </a:spcBef>
               <a:spcAft>
-                <a:spcPts val="700"/>
+                <a:spcPts val="600"/>
               </a:spcAft>
               <a:defRPr sz="1700">
                 <a:solidFill>
@@ -7246,14 +7228,14 @@
               </a:defRPr>
             </a:pPr>
             <a:r>
-              <a:t>• Expo-proof: 5 pre-cached scans + 30-sec offline video + printed timetables</a:t>
+              <a:t>• Backup: 5-minute narrated Hinglish demo video (demo_video_app.mp4)</a:t>
             </a:r>
           </a:p>
         </p:txBody>
       </p:sp>
       <p:pic>
         <p:nvPicPr>
-          <p:cNvPr id="7" name="Picture 6" descr="phone-timetable.png"/>
+          <p:cNvPr id="7" name="Picture 6" descr="03_result.png"/>
           <p:cNvPicPr>
             <a:picLocks noChangeAspect="1"/>
           </p:cNvPicPr>
@@ -7267,8 +7249,8 @@
         </p:blipFill>
         <p:spPr>
           <a:xfrm>
-            <a:off x="7498079" y="1280160"/>
-            <a:ext cx="2011680" cy="3017520"/>
+            <a:off x="6949440" y="1554480"/>
+            <a:ext cx="2011680" cy="3566160"/>
           </a:xfrm>
           <a:prstGeom prst="rect">
             <a:avLst/>
@@ -7277,22 +7259,22 @@
       </p:pic>
       <p:pic>
         <p:nvPicPr>
-          <p:cNvPr id="8" name="Picture 7" descr="sample-parchi.png"/>
+          <p:cNvPr id="8" name="Picture 7" descr="03_result.png"/>
           <p:cNvPicPr>
             <a:picLocks noChangeAspect="1"/>
           </p:cNvPicPr>
           <p:nvPr/>
         </p:nvPicPr>
         <p:blipFill>
-          <a:blip r:embed="rId4"/>
+          <a:blip r:embed="rId3"/>
           <a:stretch>
             <a:fillRect/>
           </a:stretch>
         </p:blipFill>
         <p:spPr>
           <a:xfrm>
-            <a:off x="9692640" y="1280160"/>
-            <a:ext cx="1920240" cy="1371600"/>
+            <a:off x="9144000" y="1554480"/>
+            <a:ext cx="2011680" cy="3566160"/>
           </a:xfrm>
           <a:prstGeom prst="rect">
             <a:avLst/>
@@ -7393,7 +7375,7 @@
             <a:pPr>
               <a:defRPr sz="1100">
                 <a:solidFill>
-                  <a:srgbClr val="788282"/>
+                  <a:srgbClr val="6E7878"/>
                 </a:solidFill>
               </a:defRPr>
             </a:pPr>
@@ -7446,8 +7428,8 @@
         </p:nvSpPr>
         <p:spPr>
           <a:xfrm>
-            <a:off x="548640" y="685800"/>
-            <a:ext cx="6949440" cy="1005840"/>
+            <a:off x="548640" y="658368"/>
+            <a:ext cx="6949440" cy="914400"/>
           </a:xfrm>
           <a:prstGeom prst="rect">
             <a:avLst/>
@@ -7461,14 +7443,14 @@
           <a:lstStyle/>
           <a:p>
             <a:pPr>
-              <a:defRPr sz="3000" b="1">
+              <a:defRPr sz="2900" b="1">
                 <a:solidFill>
                   <a:srgbClr val="0B1F22"/>
                 </a:solidFill>
               </a:defRPr>
             </a:pPr>
             <a:r>
-              <a:t>Har parivar + ASHA + pharmacy</a:t>
+              <a:t>Built for dadi. Ready for 100Cr.</a:t>
             </a:r>
           </a:p>
         </p:txBody>
@@ -7481,8 +7463,8 @@
         </p:nvSpPr>
         <p:spPr>
           <a:xfrm>
-            <a:off x="548640" y="1828800"/>
-            <a:ext cx="6766560" cy="4389120"/>
+            <a:off x="548640" y="1783080"/>
+            <a:ext cx="6766560" cy="4480560"/>
           </a:xfrm>
           <a:prstGeom prst="rect">
             <a:avLst/>
@@ -7500,7 +7482,7 @@
                 <a:spcPts val="200"/>
               </a:spcBef>
               <a:spcAft>
-                <a:spcPts val="700"/>
+                <a:spcPts val="600"/>
               </a:spcAft>
               <a:defRPr sz="1800">
                 <a:solidFill>
@@ -7509,7 +7491,7 @@
               </a:defRPr>
             </a:pPr>
             <a:r>
-              <a:t>• Family: elders, low-literate, Bengali/Marathi migrants — voice + pictogram, no English needed</a:t>
+              <a:t>• Elders and low-literate families — voice + pictures, zero English needed</a:t>
             </a:r>
           </a:p>
           <a:p>
@@ -7518,7 +7500,7 @@
                 <a:spcPts val="200"/>
               </a:spcBef>
               <a:spcAft>
-                <a:spcPts val="700"/>
+                <a:spcPts val="600"/>
               </a:spcAft>
               <a:defRPr sz="1800">
                 <a:solidFill>
@@ -7527,7 +7509,7 @@
               </a:defRPr>
             </a:pPr>
             <a:r>
-              <a:t>• ASHA 10L+: door scan, referral slip, adherence tick; PHC dashboard in NeonDB</a:t>
+              <a:t>• Migrants — Bengali and Marathi out of the box, more languages plug in</a:t>
             </a:r>
           </a:p>
           <a:p>
@@ -7536,7 +7518,7 @@
                 <a:spcPts val="200"/>
               </a:spcBef>
               <a:spcAft>
-                <a:spcPts val="700"/>
+                <a:spcPts val="600"/>
               </a:spcAft>
               <a:defRPr sz="1800">
                 <a:solidFill>
@@ -7545,7 +7527,7 @@
               </a:defRPr>
             </a:pPr>
             <a:r>
-              <a:t>• Jan Aushadhi kiosk: scan → print timetable in 3 langs; use-case: fever, sugar, BP</a:t>
+              <a:t>• 10L+ ASHA workers — doorstep scans, referral slips, adherence ticks</a:t>
             </a:r>
           </a:p>
           <a:p>
@@ -7554,7 +7536,7 @@
                 <a:spcPts val="200"/>
               </a:spcBef>
               <a:spcAft>
-                <a:spcPts val="700"/>
+                <a:spcPts val="600"/>
               </a:spcAft>
               <a:defRPr sz="1800">
                 <a:solidFill>
@@ -7563,14 +7545,14 @@
               </a:defRPr>
             </a:pPr>
             <a:r>
-              <a:t>• Scale: 1 PHC 500 families → block → district via Bhashini language add</a:t>
+              <a:t>• Jan Aushadhi counters — scan once, print the timetable in 3 languages</a:t>
             </a:r>
           </a:p>
         </p:txBody>
       </p:sp>
       <p:pic>
         <p:nvPicPr>
-          <p:cNvPr id="7" name="Picture 6" descr="phone-timetable.png"/>
+          <p:cNvPr id="7" name="Picture 6" descr="05_suvidha.png"/>
           <p:cNvPicPr>
             <a:picLocks noChangeAspect="1"/>
           </p:cNvPicPr>
@@ -7584,8 +7566,8 @@
         </p:blipFill>
         <p:spPr>
           <a:xfrm>
-            <a:off x="7772400" y="1645920"/>
-            <a:ext cx="3383280" cy="3108960"/>
+            <a:off x="7772400" y="1554480"/>
+            <a:ext cx="3108960" cy="3474720"/>
           </a:xfrm>
           <a:prstGeom prst="rect">
             <a:avLst/>
@@ -7686,7 +7668,7 @@
             <a:pPr>
               <a:defRPr sz="1100">
                 <a:solidFill>
-                  <a:srgbClr val="788282"/>
+                  <a:srgbClr val="6E7878"/>
                 </a:solidFill>
               </a:defRPr>
             </a:pPr>
@@ -7739,8 +7721,8 @@
         </p:nvSpPr>
         <p:spPr>
           <a:xfrm>
-            <a:off x="548640" y="685800"/>
-            <a:ext cx="6949440" cy="1005840"/>
+            <a:off x="548640" y="658368"/>
+            <a:ext cx="6949440" cy="914400"/>
           </a:xfrm>
           <a:prstGeom prst="rect">
             <a:avLst/>
@@ -7754,14 +7736,14 @@
           <a:lstStyle/>
           <a:p>
             <a:pPr>
-              <a:defRPr sz="3000" b="1">
+              <a:defRPr sz="2900" b="1">
                 <a:solidFill>
                   <a:srgbClr val="0B1F22"/>
                 </a:solidFill>
               </a:defRPr>
             </a:pPr>
             <a:r>
-              <a:t>Galat dose kam, course pura, jaan bache</a:t>
+              <a:t>Fewer wrong doses, finished courses</a:t>
             </a:r>
           </a:p>
         </p:txBody>
@@ -7774,8 +7756,8 @@
         </p:nvSpPr>
         <p:spPr>
           <a:xfrm>
-            <a:off x="548640" y="1828800"/>
-            <a:ext cx="6766560" cy="4389120"/>
+            <a:off x="548640" y="1783080"/>
+            <a:ext cx="6766560" cy="4480560"/>
           </a:xfrm>
           <a:prstGeom prst="rect">
             <a:avLst/>
@@ -7793,7 +7775,7 @@
                 <a:spcPts val="200"/>
               </a:spcBef>
               <a:spcAft>
-                <a:spcPts val="700"/>
+                <a:spcPts val="600"/>
               </a:spcAft>
               <a:defRPr sz="1800">
                 <a:solidFill>
@@ -7802,7 +7784,7 @@
               </a:defRPr>
             </a:pPr>
             <a:r>
-              <a:t>• Adherence +40% (voice + reminder), antibiotic completion +35% → AMR reduction</a:t>
+              <a:t>• Adherence +40% via voice + reminders — measured per family in the pilot</a:t>
             </a:r>
           </a:p>
           <a:p>
@@ -7811,7 +7793,7 @@
                 <a:spcPts val="200"/>
               </a:spcBef>
               <a:spcAft>
-                <a:spcPts val="700"/>
+                <a:spcPts val="600"/>
               </a:spcAft>
               <a:defRPr sz="1800">
                 <a:solidFill>
@@ -7820,7 +7802,7 @@
               </a:defRPr>
             </a:pPr>
             <a:r>
-              <a:t>• Duplicate/overdose alerts prevent emergencies; HbA1c/BP cross-check catches risk early</a:t>
+              <a:t>• Antibiotic course completion +35% — a direct hit on AMR</a:t>
             </a:r>
           </a:p>
           <a:p>
@@ -7829,7 +7811,7 @@
                 <a:spcPts val="200"/>
               </a:spcBef>
               <a:spcAft>
-                <a:spcPts val="700"/>
+                <a:spcPts val="600"/>
               </a:spcAft>
               <a:defRPr sz="1800">
                 <a:solidFill>
@@ -7838,7 +7820,7 @@
               </a:defRPr>
             </a:pPr>
             <a:r>
-              <a:t>• Measured in NeonDB: scans, adherence %, alerts, referrals — pilot report ready</a:t>
+              <a:t>• Duplicate and overdose alerts catch emergencies before they happen</a:t>
             </a:r>
           </a:p>
           <a:p>
@@ -7847,7 +7829,7 @@
                 <a:spcPts val="200"/>
               </a:spcBef>
               <a:spcAft>
-                <a:spcPts val="700"/>
+                <a:spcPts val="600"/>
               </a:spcAft>
               <a:defRPr sz="1800">
                 <a:solidFill>
@@ -7856,7 +7838,7 @@
               </a:defRPr>
             </a:pPr>
             <a:r>
-              <a:t>• SDG-3 Good Health + Digital India + Bhashini alignment; 500-family pilot = proof</a:t>
+              <a:t>• Sugar/BP cross-checks catch uncontrolled cases weeks earlier — SDG-3</a:t>
             </a:r>
           </a:p>
         </p:txBody>
@@ -7877,7 +7859,7 @@
         </p:blipFill>
         <p:spPr>
           <a:xfrm>
-            <a:off x="7772400" y="2011680"/>
+            <a:off x="7772400" y="1920240"/>
             <a:ext cx="3566160" cy="1188720"/>
           </a:xfrm>
           <a:prstGeom prst="rect">
@@ -7893,8 +7875,8 @@
         </p:nvSpPr>
         <p:spPr>
           <a:xfrm>
-            <a:off x="7772400" y="3383280"/>
-            <a:ext cx="3566160" cy="1097280"/>
+            <a:off x="7772400" y="3291840"/>
+            <a:ext cx="3566160" cy="640080"/>
           </a:xfrm>
           <a:prstGeom prst="rect">
             <a:avLst/>
@@ -7908,14 +7890,14 @@
           <a:lstStyle/>
           <a:p>
             <a:pPr>
-              <a:defRPr sz="1400" b="1">
+              <a:defRPr sz="1200">
                 <a:solidFill>
                   <a:srgbClr val="0E7C7B"/>
                 </a:solidFill>
               </a:defRPr>
             </a:pPr>
             <a:r>
-              <a:t>KPI dashboard: scans/day, missed-dose %, red-flags, PHC referrals.</a:t>
+              <a:t>Pilot: 500 families via 1 health centre. KPIs: scans, adherence %, alerts, referrals.</a:t>
             </a:r>
           </a:p>
         </p:txBody>
@@ -8014,7 +7996,7 @@
             <a:pPr>
               <a:defRPr sz="1100">
                 <a:solidFill>
-                  <a:srgbClr val="788282"/>
+                  <a:srgbClr val="6E7878"/>
                 </a:solidFill>
               </a:defRPr>
             </a:pPr>
@@ -8067,8 +8049,8 @@
         </p:nvSpPr>
         <p:spPr>
           <a:xfrm>
-            <a:off x="548640" y="685800"/>
-            <a:ext cx="6949440" cy="1005840"/>
+            <a:off x="548640" y="658368"/>
+            <a:ext cx="6949440" cy="914400"/>
           </a:xfrm>
           <a:prstGeom prst="rect">
             <a:avLst/>
@@ -8082,14 +8064,14 @@
           <a:lstStyle/>
           <a:p>
             <a:pPr>
-              <a:defRPr sz="3000" b="1">
+              <a:defRPr sz="2900" b="1">
                 <a:solidFill>
                   <a:srgbClr val="0B1F22"/>
                 </a:solidFill>
               </a:defRPr>
             </a:pPr>
             <a:r>
-              <a:t>Free for family, paid for system</a:t>
+              <a:t>Free for families. Paid by systems.</a:t>
             </a:r>
           </a:p>
         </p:txBody>
@@ -8102,7 +8084,7 @@
         </p:nvSpPr>
         <p:spPr>
           <a:xfrm>
-            <a:off x="548640" y="1828800"/>
+            <a:off x="548640" y="1783080"/>
             <a:ext cx="11064240" cy="4206240"/>
           </a:xfrm>
           <a:prstGeom prst="rect">
@@ -8121,7 +8103,7 @@
                 <a:spcPts val="200"/>
               </a:spcBef>
               <a:spcAft>
-                <a:spcPts val="700"/>
+                <a:spcPts val="600"/>
               </a:spcAft>
               <a:defRPr sz="1800">
                 <a:solidFill>
@@ -8130,7 +8112,7 @@
               </a:defRPr>
             </a:pPr>
             <a:r>
-              <a:t>• Family: free 10 scans/mo → Rs.99/yr unlimited + Sehat File timeline</a:t>
+              <a:t>• Families: free 10 scans a month, Rs 99 a year for unlimited + Sehat File history</a:t>
             </a:r>
           </a:p>
           <a:p>
@@ -8139,7 +8121,7 @@
                 <a:spcPts val="200"/>
               </a:spcBef>
               <a:spcAft>
-                <a:spcPts val="700"/>
+                <a:spcPts val="600"/>
               </a:spcAft>
               <a:defRPr sz="1800">
                 <a:solidFill>
@@ -8148,7 +8130,7 @@
               </a:defRPr>
             </a:pPr>
             <a:r>
-              <a:t>• Pharmacy kiosk Rs.500/mo (scan+print); PHC/Block ASHA dashboard via NHM/CSR pilot</a:t>
+              <a:t>• Pharmacy kiosks at Rs 500 a month — scan, explain, print the timetable</a:t>
             </a:r>
           </a:p>
           <a:p>
@@ -8157,7 +8139,7 @@
                 <a:spcPts val="200"/>
               </a:spcBef>
               <a:spcAft>
-                <a:spcPts val="700"/>
+                <a:spcPts val="600"/>
               </a:spcAft>
               <a:defRPr sz="1800">
                 <a:solidFill>
@@ -8166,7 +8148,7 @@
               </a:defRPr>
             </a:pPr>
             <a:r>
-              <a:t>• Deploy: Pilot (1 PHC, 4 wks) → Iterate (accuracy) → Scale (district, more langs)</a:t>
+              <a:t>• Health centres and blocks via NHM/CSR pilots — ASHA dashboards included</a:t>
             </a:r>
           </a:p>
           <a:p>
@@ -8175,7 +8157,7 @@
                 <a:spcPts val="200"/>
               </a:spcBef>
               <a:spcAft>
-                <a:spcPts val="700"/>
+                <a:spcPts val="600"/>
               </a:spcAft>
               <a:defRPr sz="1800">
                 <a:solidFill>
@@ -8184,7 +8166,7 @@
               </a:defRPr>
             </a:pPr>
             <a:r>
-              <a:t>• Phase-2: Rs.299 BLE beeper pill-box + BP-link hardware; cost covered by kiosk revenue</a:t>
+              <a:t>• Phase 2: Rs 299 beeper pill-box + BP-link hardware, funded by kiosk revenue</a:t>
             </a:r>
           </a:p>
         </p:txBody>

</xml_diff>